<commit_message>
Update to use arcade and clean ups
</commit_message>
<xml_diff>
--- a/module-02-line-tracking/slides/07-detecting-intersections.pptx
+++ b/module-02-line-tracking/slides/07-detecting-intersections.pptx
@@ -4902,7 +4902,7 @@
               </a:defRPr>
             </a:pPr>
             <a:r>
-              <a:t>        left_effort  = base_effort - error * Kp</a:t>
+              <a:t>        correction = error * Kp</a:t>
             </a:r>
           </a:p>
           <a:p>
@@ -4918,7 +4918,7 @@
               </a:defRPr>
             </a:pPr>
             <a:r>
-              <a:t>        right_effort = base_effort + error * Kp</a:t>
+              <a:t>        drivetrain.arcade(base_effort, -correction)</a:t>
             </a:r>
           </a:p>
           <a:p>
@@ -4934,7 +4934,7 @@
               </a:defRPr>
             </a:pPr>
             <a:r>
-              <a:t>        drivetrain.set_effort(left_effort, right_effort)</a:t>
+              <a:t/>
             </a:r>
           </a:p>
         </p:txBody>

</xml_diff>

<commit_message>
cleaned up some slides
</commit_message>
<xml_diff>
--- a/module-02-line-tracking/slides/07-detecting-intersections.pptx
+++ b/module-02-line-tracking/slides/07-detecting-intersections.pptx
@@ -14,6 +14,7 @@
     <p:sldId id="262" r:id="rId13"/>
     <p:sldId id="263" r:id="rId14"/>
     <p:sldId id="264" r:id="rId15"/>
+    <p:sldId id="265" r:id="rId16"/>
   </p:sldIdLst>
   <p:sldSz cx="12191695" cy="6858000" type="screen4x3"/>
   <p:notesSz cx="6858000" cy="9144000"/>
@@ -3391,6 +3392,281 @@
             </a:pPr>
             <a:r>
               <a:t>Follow + detect + reverse  (20 min)</a:t>
+            </a:r>
+          </a:p>
+        </p:txBody>
+      </p:sp>
+    </p:spTree>
+  </p:cSld>
+  <p:clrMapOvr>
+    <a:masterClrMapping/>
+  </p:clrMapOvr>
+</p:sld>
+</file>
+
+<file path=ppt/slides/slide10.xml><?xml version="1.0" encoding="utf-8"?>
+<p:sld xmlns:a="http://schemas.openxmlformats.org/drawingml/2006/main" xmlns:p="http://schemas.openxmlformats.org/presentationml/2006/main" xmlns:r="http://schemas.openxmlformats.org/officeDocument/2006/relationships">
+  <p:cSld>
+    <p:spTree>
+      <p:nvGrpSpPr>
+        <p:cNvPr id="1" name=""/>
+        <p:cNvGrpSpPr/>
+        <p:nvPr/>
+      </p:nvGrpSpPr>
+      <p:grpSpPr/>
+      <p:sp>
+        <p:nvSpPr>
+          <p:cNvPr id="2" name="Rectangle 1"/>
+          <p:cNvSpPr/>
+          <p:nvPr/>
+        </p:nvSpPr>
+        <p:spPr>
+          <a:xfrm>
+            <a:off x="0" y="0"/>
+            <a:ext cx="12191695" cy="1097280"/>
+          </a:xfrm>
+          <a:prstGeom prst="rect">
+            <a:avLst/>
+          </a:prstGeom>
+          <a:solidFill>
+            <a:srgbClr val="1B3A5C"/>
+          </a:solidFill>
+          <a:ln>
+            <a:noFill/>
+          </a:ln>
+        </p:spPr>
+        <p:style>
+          <a:lnRef idx="1">
+            <a:schemeClr val="accent1"/>
+          </a:lnRef>
+          <a:fillRef idx="3">
+            <a:schemeClr val="accent1"/>
+          </a:fillRef>
+          <a:effectRef idx="2">
+            <a:schemeClr val="accent1"/>
+          </a:effectRef>
+          <a:fontRef idx="minor">
+            <a:schemeClr val="lt1"/>
+          </a:fontRef>
+        </p:style>
+        <p:txBody>
+          <a:bodyPr rtlCol="0" anchor="ctr"/>
+          <a:lstStyle/>
+          <a:p>
+            <a:pPr algn="ctr"/>
+          </a:p>
+        </p:txBody>
+      </p:sp>
+      <p:sp>
+        <p:nvSpPr>
+          <p:cNvPr id="3" name="TextBox 2"/>
+          <p:cNvSpPr txBox="1"/>
+          <p:nvPr/>
+        </p:nvSpPr>
+        <p:spPr>
+          <a:xfrm>
+            <a:off x="548640" y="137160"/>
+            <a:ext cx="10972800" cy="822960"/>
+          </a:xfrm>
+          <a:prstGeom prst="rect">
+            <a:avLst/>
+          </a:prstGeom>
+          <a:noFill/>
+        </p:spPr>
+        <p:txBody>
+          <a:bodyPr wrap="square">
+            <a:spAutoFit/>
+          </a:bodyPr>
+          <a:lstStyle/>
+          <a:p>
+            <a:pPr>
+              <a:defRPr sz="3200" b="1">
+                <a:solidFill>
+                  <a:srgbClr val="FFFFFF"/>
+                </a:solidFill>
+                <a:latin typeface="Calibri"/>
+              </a:defRPr>
+            </a:pPr>
+            <a:r>
+              <a:t>Connection to Next Lesson</a:t>
+            </a:r>
+          </a:p>
+        </p:txBody>
+      </p:sp>
+      <p:sp>
+        <p:nvSpPr>
+          <p:cNvPr id="4" name="TextBox 3"/>
+          <p:cNvSpPr txBox="1"/>
+          <p:nvPr/>
+        </p:nvSpPr>
+        <p:spPr>
+          <a:xfrm>
+            <a:off x="548640" y="1371600"/>
+            <a:ext cx="10972800" cy="5029200"/>
+          </a:xfrm>
+          <a:prstGeom prst="rect">
+            <a:avLst/>
+          </a:prstGeom>
+          <a:noFill/>
+        </p:spPr>
+        <p:txBody>
+          <a:bodyPr wrap="square">
+            <a:spAutoFit/>
+          </a:bodyPr>
+          <a:lstStyle/>
+          <a:p/>
+          <a:p>
+            <a:pPr>
+              <a:spcAft>
+                <a:spcPts val="600"/>
+              </a:spcAft>
+              <a:defRPr sz="2200" b="1">
+                <a:solidFill>
+                  <a:srgbClr val="1B3A5C"/>
+                </a:solidFill>
+                <a:latin typeface="Calibri"/>
+              </a:defRPr>
+            </a:pPr>
+            <a:r>
+              <a:t>What you’ve built so far (all as loose code):</a:t>
+            </a:r>
+          </a:p>
+          <a:p>
+            <a:pPr>
+              <a:spcAft>
+                <a:spcPts val="600"/>
+              </a:spcAft>
+              <a:defRPr sz="1800" b="0">
+                <a:solidFill>
+                  <a:srgbClr val="333333"/>
+                </a:solidFill>
+                <a:latin typeface="Calibri"/>
+              </a:defRPr>
+            </a:pPr>
+            <a:r>
+              <a:t>Sensor reading, error calculation, cross detection</a:t>
+            </a:r>
+          </a:p>
+          <a:p>
+            <a:pPr>
+              <a:spcAft>
+                <a:spcPts val="600"/>
+              </a:spcAft>
+              <a:defRPr sz="1800" b="0">
+                <a:solidFill>
+                  <a:srgbClr val="333333"/>
+                </a:solidFill>
+                <a:latin typeface="Calibri"/>
+              </a:defRPr>
+            </a:pPr>
+            <a:r>
+              <a:t>Proportional control, differential steering</a:t>
+            </a:r>
+          </a:p>
+          <a:p>
+            <a:pPr>
+              <a:spcAft>
+                <a:spcPts val="600"/>
+              </a:spcAft>
+              <a:defRPr sz="1800" b="0">
+                <a:solidFill>
+                  <a:srgbClr val="333333"/>
+                </a:solidFill>
+                <a:latin typeface="Calibri"/>
+              </a:defRPr>
+            </a:pPr>
+            <a:r>
+              <a:t>All mixed together in one big program</a:t>
+            </a:r>
+          </a:p>
+          <a:p>
+            <a:pPr>
+              <a:spcAft>
+                <a:spcPts val="600"/>
+              </a:spcAft>
+              <a:defRPr sz="1800" b="0">
+                <a:solidFill>
+                  <a:srgbClr val="000000"/>
+                </a:solidFill>
+                <a:latin typeface="Calibri"/>
+              </a:defRPr>
+            </a:pPr>
+          </a:p>
+          <a:p>
+            <a:pPr>
+              <a:spcAft>
+                <a:spcPts val="600"/>
+              </a:spcAft>
+              <a:defRPr sz="2200" b="1">
+                <a:solidFill>
+                  <a:srgbClr val="1B3A5C"/>
+                </a:solidFill>
+                <a:latin typeface="Calibri"/>
+              </a:defRPr>
+            </a:pPr>
+            <a:r>
+              <a:t>Next (Lesson 8): Package sensor logic into a LineSensor class</a:t>
+            </a:r>
+          </a:p>
+          <a:p>
+            <a:pPr>
+              <a:spcAft>
+                <a:spcPts val="600"/>
+              </a:spcAft>
+              <a:defRPr sz="1800" b="0">
+                <a:solidFill>
+                  <a:srgbClr val="333333"/>
+                </a:solidFill>
+                <a:latin typeface="Calibri"/>
+              </a:defRPr>
+            </a:pPr>
+            <a:r>
+              <a:t>get_error(),  is_at_cross(),  is_off_line()</a:t>
+            </a:r>
+          </a:p>
+          <a:p>
+            <a:pPr>
+              <a:spcAft>
+                <a:spcPts val="600"/>
+              </a:spcAft>
+              <a:defRPr sz="1800" b="0">
+                <a:solidFill>
+                  <a:srgbClr val="333333"/>
+                </a:solidFill>
+                <a:latin typeface="Calibri"/>
+              </a:defRPr>
+            </a:pPr>
+            <a:r>
+              <a:t>First time writing a Python class!</a:t>
+            </a:r>
+          </a:p>
+          <a:p>
+            <a:pPr>
+              <a:spcAft>
+                <a:spcPts val="600"/>
+              </a:spcAft>
+              <a:defRPr sz="1800" b="0">
+                <a:solidFill>
+                  <a:srgbClr val="000000"/>
+                </a:solidFill>
+                <a:latin typeface="Calibri"/>
+              </a:defRPr>
+            </a:pPr>
+          </a:p>
+          <a:p>
+            <a:pPr>
+              <a:spcAft>
+                <a:spcPts val="600"/>
+              </a:spcAft>
+              <a:defRPr sz="2000" b="1">
+                <a:solidFill>
+                  <a:srgbClr val="2E75B6"/>
+                </a:solidFill>
+                <a:latin typeface="Calibri"/>
+              </a:defRPr>
+            </a:pPr>
+            <a:r>
+              <a:t>Why? Organized code is easier to understand, test, and reuse.</a:t>
             </a:r>
           </a:p>
         </p:txBody>
@@ -4902,7 +5178,7 @@
               </a:defRPr>
             </a:pPr>
             <a:r>
-              <a:t>        correction = error * Kp</a:t>
+              <a:t>        left_effort  = base_effort - error * Kp</a:t>
             </a:r>
           </a:p>
           <a:p>
@@ -4918,7 +5194,7 @@
               </a:defRPr>
             </a:pPr>
             <a:r>
-              <a:t>        drivetrain.arcade(base_effort, -correction)</a:t>
+              <a:t>        right_effort = base_effort + error * Kp</a:t>
             </a:r>
           </a:p>
           <a:p>
@@ -4934,7 +5210,7 @@
               </a:defRPr>
             </a:pPr>
             <a:r>
-              <a:t/>
+              <a:t>        drivetrain.set_effort(left_effort, right_effort)</a:t>
             </a:r>
           </a:p>
         </p:txBody>
@@ -5856,7 +6132,7 @@
               </a:defRPr>
             </a:pPr>
             <a:r>
-              <a:t>Your Turn!</a:t>
+              <a:t>Alternative — Using a Function and a for Loop</a:t>
             </a:r>
           </a:p>
         </p:txBody>
@@ -5869,8 +6145,8 @@
         </p:nvSpPr>
         <p:spPr>
           <a:xfrm>
-            <a:off x="548640" y="1371600"/>
-            <a:ext cx="5943600" cy="4572000"/>
+            <a:off x="548640" y="1280160"/>
+            <a:ext cx="10972800" cy="731520"/>
           </a:xfrm>
           <a:prstGeom prst="rect">
             <a:avLst/>
@@ -5888,7 +6164,7 @@
               <a:spcAft>
                 <a:spcPts val="600"/>
               </a:spcAft>
-              <a:defRPr sz="2200" b="1">
+              <a:defRPr sz="2000" b="1">
                 <a:solidFill>
                   <a:srgbClr val="1B3A5C"/>
                 </a:solidFill>
@@ -5896,7 +6172,7 @@
               </a:defRPr>
             </a:pPr>
             <a:r>
-              <a:t>Exercise 1:</a:t>
+              <a:t>Another way to count crossings:</a:t>
             </a:r>
           </a:p>
           <a:p>
@@ -5912,114 +6188,66 @@
               </a:defRPr>
             </a:pPr>
             <a:r>
-              <a:t>Follow the circle and reverse at the cross</a:t>
-            </a:r>
-          </a:p>
-          <a:p>
-            <a:pPr lvl="1">
-              <a:spcAft>
-                <a:spcPts val="600"/>
-              </a:spcAft>
-              <a:defRPr sz="1700" b="0">
-                <a:solidFill>
-                  <a:srgbClr val="333333"/>
-                </a:solidFill>
-                <a:latin typeface="Calibri"/>
-              </a:defRPr>
-            </a:pPr>
-            <a:r>
-              <a:t>Use two-sensor line following from Lesson 6</a:t>
-            </a:r>
-          </a:p>
-          <a:p>
-            <a:pPr lvl="1">
-              <a:spcAft>
-                <a:spcPts val="600"/>
-              </a:spcAft>
-              <a:defRPr sz="1700" b="0">
-                <a:solidFill>
-                  <a:srgbClr val="333333"/>
-                </a:solidFill>
-                <a:latin typeface="Calibri"/>
-              </a:defRPr>
-            </a:pPr>
-            <a:r>
-              <a:t>Add cross detection with and</a:t>
-            </a:r>
-          </a:p>
-          <a:p>
-            <a:pPr lvl="1">
-              <a:spcAft>
-                <a:spcPts val="600"/>
-              </a:spcAft>
-              <a:defRPr sz="1700" b="0">
-                <a:solidFill>
-                  <a:srgbClr val="333333"/>
-                </a:solidFill>
-                <a:latin typeface="Calibri"/>
-              </a:defRPr>
-            </a:pPr>
-            <a:r>
-              <a:t>Turn 180° when cross is detected</a:t>
-            </a:r>
-          </a:p>
-          <a:p>
-            <a:pPr>
-              <a:spcAft>
-                <a:spcPts val="600"/>
-              </a:spcAft>
-              <a:defRPr sz="1800" b="0">
-                <a:solidFill>
-                  <a:srgbClr val="000000"/>
-                </a:solidFill>
-                <a:latin typeface="Calibri"/>
-              </a:defRPr>
-            </a:pPr>
-          </a:p>
-          <a:p>
-            <a:pPr>
-              <a:spcAft>
-                <a:spcPts val="600"/>
-              </a:spcAft>
-              <a:defRPr sz="2200" b="1">
-                <a:solidFill>
-                  <a:srgbClr val="1B3A5C"/>
-                </a:solidFill>
-                <a:latin typeface="Calibri"/>
-              </a:defRPr>
-            </a:pPr>
-            <a:r>
-              <a:t>Exercise 2 (Challenge):</a:t>
-            </a:r>
-          </a:p>
-          <a:p>
-            <a:pPr>
-              <a:spcAft>
-                <a:spcPts val="600"/>
-              </a:spcAft>
-              <a:defRPr sz="1800" b="0">
-                <a:solidFill>
-                  <a:srgbClr val="333333"/>
-                </a:solidFill>
-                <a:latin typeface="Calibri"/>
-              </a:defRPr>
-            </a:pPr>
-            <a:r>
-              <a:t>Count crossings and stop after 4</a:t>
-            </a:r>
-          </a:p>
-        </p:txBody>
-      </p:sp>
-      <p:sp>
-        <p:nvSpPr>
-          <p:cNvPr id="5" name="TextBox 4"/>
+              <a:t>Write a function that line-follows until it hits a cross, then use a for loop to call it 4 times.</a:t>
+            </a:r>
+          </a:p>
+        </p:txBody>
+      </p:sp>
+      <p:sp>
+        <p:nvSpPr>
+          <p:cNvPr id="5" name="Rounded Rectangle 4"/>
+          <p:cNvSpPr/>
+          <p:nvPr/>
+        </p:nvSpPr>
+        <p:spPr>
+          <a:xfrm>
+            <a:off x="548640" y="2468880"/>
+            <a:ext cx="7315200" cy="4206240"/>
+          </a:xfrm>
+          <a:prstGeom prst="roundRect">
+            <a:avLst/>
+          </a:prstGeom>
+          <a:solidFill>
+            <a:srgbClr val="F0F0F0"/>
+          </a:solidFill>
+          <a:ln w="12700">
+            <a:solidFill>
+              <a:srgbClr val="999999"/>
+            </a:solidFill>
+          </a:ln>
+        </p:spPr>
+        <p:style>
+          <a:lnRef idx="1">
+            <a:schemeClr val="accent1"/>
+          </a:lnRef>
+          <a:fillRef idx="3">
+            <a:schemeClr val="accent1"/>
+          </a:fillRef>
+          <a:effectRef idx="2">
+            <a:schemeClr val="accent1"/>
+          </a:effectRef>
+          <a:fontRef idx="minor">
+            <a:schemeClr val="lt1"/>
+          </a:fontRef>
+        </p:style>
+        <p:txBody>
+          <a:bodyPr rtlCol="0" anchor="ctr"/>
+          <a:lstStyle/>
+          <a:p>
+            <a:pPr algn="ctr"/>
+          </a:p>
+        </p:txBody>
+      </p:sp>
+      <p:sp>
+        <p:nvSpPr>
+          <p:cNvPr id="6" name="TextBox 5"/>
           <p:cNvSpPr txBox="1"/>
           <p:nvPr/>
         </p:nvSpPr>
         <p:spPr>
           <a:xfrm>
-            <a:off x="6858000" y="1371600"/>
-            <a:ext cx="4572000" cy="2743200"/>
+            <a:off x="731520" y="2606040"/>
+            <a:ext cx="6949440" cy="3931920"/>
           </a:xfrm>
           <a:prstGeom prst="rect">
             <a:avLst/>
@@ -6027,6 +6255,324 @@
           <a:noFill/>
         </p:spPr>
         <p:txBody>
+          <a:bodyPr wrap="none">
+            <a:spAutoFit/>
+          </a:bodyPr>
+          <a:lstStyle/>
+          <a:p>
+            <a:pPr>
+              <a:spcAft>
+                <a:spcPts val="200"/>
+              </a:spcAft>
+              <a:defRPr sz="1200">
+                <a:solidFill>
+                  <a:srgbClr val="333333"/>
+                </a:solidFill>
+                <a:latin typeface="Courier New"/>
+              </a:defRPr>
+            </a:pPr>
+            <a:r>
+              <a:t>def drive_to_cross():</a:t>
+            </a:r>
+          </a:p>
+          <a:p>
+            <a:pPr>
+              <a:spcAft>
+                <a:spcPts val="200"/>
+              </a:spcAft>
+              <a:defRPr sz="1200">
+                <a:solidFill>
+                  <a:srgbClr val="333333"/>
+                </a:solidFill>
+                <a:latin typeface="Courier New"/>
+              </a:defRPr>
+            </a:pPr>
+            <a:r>
+              <a:t>    """Line-follow until a cross is detected."""</a:t>
+            </a:r>
+          </a:p>
+          <a:p>
+            <a:pPr>
+              <a:spcAft>
+                <a:spcPts val="200"/>
+              </a:spcAft>
+              <a:defRPr sz="1200">
+                <a:solidFill>
+                  <a:srgbClr val="333333"/>
+                </a:solidFill>
+                <a:latin typeface="Courier New"/>
+              </a:defRPr>
+            </a:pPr>
+            <a:r>
+              <a:t>    while True:</a:t>
+            </a:r>
+          </a:p>
+          <a:p>
+            <a:pPr>
+              <a:spcAft>
+                <a:spcPts val="200"/>
+              </a:spcAft>
+              <a:defRPr sz="1200">
+                <a:solidFill>
+                  <a:srgbClr val="333333"/>
+                </a:solidFill>
+                <a:latin typeface="Courier New"/>
+              </a:defRPr>
+            </a:pPr>
+            <a:r>
+              <a:t>        left  = reflectance.get_left()</a:t>
+            </a:r>
+          </a:p>
+          <a:p>
+            <a:pPr>
+              <a:spcAft>
+                <a:spcPts val="200"/>
+              </a:spcAft>
+              <a:defRPr sz="1200">
+                <a:solidFill>
+                  <a:srgbClr val="333333"/>
+                </a:solidFill>
+                <a:latin typeface="Courier New"/>
+              </a:defRPr>
+            </a:pPr>
+            <a:r>
+              <a:t>        right = reflectance.get_right()</a:t>
+            </a:r>
+          </a:p>
+          <a:p>
+            <a:pPr>
+              <a:spcAft>
+                <a:spcPts val="200"/>
+              </a:spcAft>
+              <a:defRPr sz="1200">
+                <a:solidFill>
+                  <a:srgbClr val="333333"/>
+                </a:solidFill>
+                <a:latin typeface="Courier New"/>
+              </a:defRPr>
+            </a:pPr>
+          </a:p>
+          <a:p>
+            <a:pPr>
+              <a:spcAft>
+                <a:spcPts val="200"/>
+              </a:spcAft>
+              <a:defRPr sz="1200">
+                <a:solidFill>
+                  <a:srgbClr val="333333"/>
+                </a:solidFill>
+                <a:latin typeface="Courier New"/>
+              </a:defRPr>
+            </a:pPr>
+            <a:r>
+              <a:t>        if left &gt; threshold and right &gt; threshold:</a:t>
+            </a:r>
+          </a:p>
+          <a:p>
+            <a:pPr>
+              <a:spcAft>
+                <a:spcPts val="200"/>
+              </a:spcAft>
+              <a:defRPr sz="1200">
+                <a:solidFill>
+                  <a:srgbClr val="333333"/>
+                </a:solidFill>
+                <a:latin typeface="Courier New"/>
+              </a:defRPr>
+            </a:pPr>
+            <a:r>
+              <a:t>            drivetrain.stop()</a:t>
+            </a:r>
+          </a:p>
+          <a:p>
+            <a:pPr>
+              <a:spcAft>
+                <a:spcPts val="200"/>
+              </a:spcAft>
+              <a:defRPr sz="1200">
+                <a:solidFill>
+                  <a:srgbClr val="333333"/>
+                </a:solidFill>
+                <a:latin typeface="Courier New"/>
+              </a:defRPr>
+            </a:pPr>
+            <a:r>
+              <a:t>            return              # cross found — done</a:t>
+            </a:r>
+          </a:p>
+          <a:p>
+            <a:pPr>
+              <a:spcAft>
+                <a:spcPts val="200"/>
+              </a:spcAft>
+              <a:defRPr sz="1200">
+                <a:solidFill>
+                  <a:srgbClr val="333333"/>
+                </a:solidFill>
+                <a:latin typeface="Courier New"/>
+              </a:defRPr>
+            </a:pPr>
+          </a:p>
+          <a:p>
+            <a:pPr>
+              <a:spcAft>
+                <a:spcPts val="200"/>
+              </a:spcAft>
+              <a:defRPr sz="1200">
+                <a:solidFill>
+                  <a:srgbClr val="333333"/>
+                </a:solidFill>
+                <a:latin typeface="Courier New"/>
+              </a:defRPr>
+            </a:pPr>
+            <a:r>
+              <a:t>        # normal line following</a:t>
+            </a:r>
+          </a:p>
+          <a:p>
+            <a:pPr>
+              <a:spcAft>
+                <a:spcPts val="200"/>
+              </a:spcAft>
+              <a:defRPr sz="1200">
+                <a:solidFill>
+                  <a:srgbClr val="333333"/>
+                </a:solidFill>
+                <a:latin typeface="Courier New"/>
+              </a:defRPr>
+            </a:pPr>
+            <a:r>
+              <a:t>        error = left - right</a:t>
+            </a:r>
+          </a:p>
+          <a:p>
+            <a:pPr>
+              <a:spcAft>
+                <a:spcPts val="200"/>
+              </a:spcAft>
+              <a:defRPr sz="1200">
+                <a:solidFill>
+                  <a:srgbClr val="333333"/>
+                </a:solidFill>
+                <a:latin typeface="Courier New"/>
+              </a:defRPr>
+            </a:pPr>
+            <a:r>
+              <a:t>        correction = error * Kp</a:t>
+            </a:r>
+          </a:p>
+          <a:p>
+            <a:pPr>
+              <a:spcAft>
+                <a:spcPts val="200"/>
+              </a:spcAft>
+              <a:defRPr sz="1200">
+                <a:solidFill>
+                  <a:srgbClr val="333333"/>
+                </a:solidFill>
+                <a:latin typeface="Courier New"/>
+              </a:defRPr>
+            </a:pPr>
+            <a:r>
+              <a:t>        drivetrain.arcade(base_effort, -correction)</a:t>
+            </a:r>
+          </a:p>
+          <a:p>
+            <a:pPr>
+              <a:spcAft>
+                <a:spcPts val="200"/>
+              </a:spcAft>
+              <a:defRPr sz="1200">
+                <a:solidFill>
+                  <a:srgbClr val="333333"/>
+                </a:solidFill>
+                <a:latin typeface="Courier New"/>
+              </a:defRPr>
+            </a:pPr>
+          </a:p>
+          <a:p>
+            <a:pPr>
+              <a:spcAft>
+                <a:spcPts val="200"/>
+              </a:spcAft>
+              <a:defRPr sz="1200">
+                <a:solidFill>
+                  <a:srgbClr val="333333"/>
+                </a:solidFill>
+                <a:latin typeface="Courier New"/>
+              </a:defRPr>
+            </a:pPr>
+            <a:r>
+              <a:t>for i in range(4):</a:t>
+            </a:r>
+          </a:p>
+          <a:p>
+            <a:pPr>
+              <a:spcAft>
+                <a:spcPts val="200"/>
+              </a:spcAft>
+              <a:defRPr sz="1200">
+                <a:solidFill>
+                  <a:srgbClr val="333333"/>
+                </a:solidFill>
+                <a:latin typeface="Courier New"/>
+              </a:defRPr>
+            </a:pPr>
+            <a:r>
+              <a:t>    drive_to_cross()</a:t>
+            </a:r>
+          </a:p>
+          <a:p>
+            <a:pPr>
+              <a:spcAft>
+                <a:spcPts val="200"/>
+              </a:spcAft>
+              <a:defRPr sz="1200">
+                <a:solidFill>
+                  <a:srgbClr val="333333"/>
+                </a:solidFill>
+                <a:latin typeface="Courier New"/>
+              </a:defRPr>
+            </a:pPr>
+            <a:r>
+              <a:t>    drivetrain.turn(180)</a:t>
+            </a:r>
+          </a:p>
+          <a:p>
+            <a:pPr>
+              <a:spcAft>
+                <a:spcPts val="200"/>
+              </a:spcAft>
+              <a:defRPr sz="1200">
+                <a:solidFill>
+                  <a:srgbClr val="333333"/>
+                </a:solidFill>
+                <a:latin typeface="Courier New"/>
+              </a:defRPr>
+            </a:pPr>
+            <a:r>
+              <a:t>    time.sleep(0.3)</a:t>
+            </a:r>
+          </a:p>
+        </p:txBody>
+      </p:sp>
+      <p:sp>
+        <p:nvSpPr>
+          <p:cNvPr id="7" name="TextBox 6"/>
+          <p:cNvSpPr txBox="1"/>
+          <p:nvPr/>
+        </p:nvSpPr>
+        <p:spPr>
+          <a:xfrm>
+            <a:off x="8046720" y="2468880"/>
+            <a:ext cx="3931920" cy="4114800"/>
+          </a:xfrm>
+          <a:prstGeom prst="rect">
+            <a:avLst/>
+          </a:prstGeom>
+          <a:noFill/>
+        </p:spPr>
+        <p:txBody>
           <a:bodyPr wrap="square">
             <a:spAutoFit/>
           </a:bodyPr>
@@ -6037,7 +6583,84 @@
               <a:spcAft>
                 <a:spcPts val="600"/>
               </a:spcAft>
-              <a:defRPr sz="2200" b="1">
+              <a:defRPr sz="1800" b="1">
+                <a:solidFill>
+                  <a:srgbClr val="1B3A5C"/>
+                </a:solidFill>
+                <a:latin typeface="Calibri"/>
+              </a:defRPr>
+            </a:pPr>
+            <a:r>
+              <a:t>Why this is nice:</a:t>
+            </a:r>
+          </a:p>
+          <a:p>
+            <a:pPr>
+              <a:spcAft>
+                <a:spcPts val="600"/>
+              </a:spcAft>
+              <a:defRPr sz="1600" b="0">
+                <a:solidFill>
+                  <a:srgbClr val="333333"/>
+                </a:solidFill>
+                <a:latin typeface="Calibri"/>
+              </a:defRPr>
+            </a:pPr>
+            <a:r>
+              <a:t>The function does ONE job: drive until a cross</a:t>
+            </a:r>
+          </a:p>
+          <a:p>
+            <a:pPr>
+              <a:spcAft>
+                <a:spcPts val="600"/>
+              </a:spcAft>
+              <a:defRPr sz="1600" b="0">
+                <a:solidFill>
+                  <a:srgbClr val="333333"/>
+                </a:solidFill>
+                <a:latin typeface="Calibri"/>
+              </a:defRPr>
+            </a:pPr>
+            <a:r>
+              <a:t>The for loop is simple and clear: do it 4 times</a:t>
+            </a:r>
+          </a:p>
+          <a:p>
+            <a:pPr>
+              <a:spcAft>
+                <a:spcPts val="600"/>
+              </a:spcAft>
+              <a:defRPr sz="1600" b="0">
+                <a:solidFill>
+                  <a:srgbClr val="333333"/>
+                </a:solidFill>
+                <a:latin typeface="Calibri"/>
+              </a:defRPr>
+            </a:pPr>
+            <a:r>
+              <a:t>Easy to change: want 6 crosses? Just change range(4) to range(6)</a:t>
+            </a:r>
+          </a:p>
+          <a:p>
+            <a:pPr>
+              <a:spcAft>
+                <a:spcPts val="600"/>
+              </a:spcAft>
+              <a:defRPr sz="1800" b="0">
+                <a:solidFill>
+                  <a:srgbClr val="000000"/>
+                </a:solidFill>
+                <a:latin typeface="Calibri"/>
+              </a:defRPr>
+            </a:pPr>
+          </a:p>
+          <a:p>
+            <a:pPr>
+              <a:spcAft>
+                <a:spcPts val="600"/>
+              </a:spcAft>
+              <a:defRPr sz="1800" b="1">
                 <a:solidFill>
                   <a:srgbClr val="2E75B6"/>
                 </a:solidFill>
@@ -6045,23 +6668,7 @@
               </a:defRPr>
             </a:pPr>
             <a:r>
-              <a:t>Test:</a:t>
-            </a:r>
-          </a:p>
-          <a:p>
-            <a:pPr>
-              <a:spcAft>
-                <a:spcPts val="600"/>
-              </a:spcAft>
-              <a:defRPr sz="1800" b="0">
-                <a:solidFill>
-                  <a:srgbClr val="333333"/>
-                </a:solidFill>
-                <a:latin typeface="Calibri"/>
-              </a:defRPr>
-            </a:pPr>
-            <a:r>
-              <a:t>Does the robot reliably detect the cross?</a:t>
+              <a:t>Same result, different style!</a:t>
             </a:r>
           </a:p>
         </p:txBody>
@@ -6158,7 +6765,7 @@
               </a:defRPr>
             </a:pPr>
             <a:r>
-              <a:t>Connection to Next Lesson</a:t>
+              <a:t>Your Turn!</a:t>
             </a:r>
           </a:p>
         </p:txBody>
@@ -6172,7 +6779,7 @@
         <p:spPr>
           <a:xfrm>
             <a:off x="548640" y="1371600"/>
-            <a:ext cx="10972800" cy="5029200"/>
+            <a:ext cx="5943600" cy="4572000"/>
           </a:xfrm>
           <a:prstGeom prst="rect">
             <a:avLst/>
@@ -6198,7 +6805,7 @@
               </a:defRPr>
             </a:pPr>
             <a:r>
-              <a:t>What you’ve built so far (all as loose code):</a:t>
+              <a:t>Exercise 1:</a:t>
             </a:r>
           </a:p>
           <a:p>
@@ -6214,30 +6821,91 @@
               </a:defRPr>
             </a:pPr>
             <a:r>
-              <a:t>Sensor reading, error calculation, cross detection</a:t>
-            </a:r>
-          </a:p>
-          <a:p>
-            <a:pPr>
+              <a:t>Follow the circle and reverse at the cross</a:t>
+            </a:r>
+          </a:p>
+          <a:p>
+            <a:pPr lvl="1">
               <a:spcAft>
                 <a:spcPts val="600"/>
               </a:spcAft>
+              <a:defRPr sz="1700" b="0">
+                <a:solidFill>
+                  <a:srgbClr val="333333"/>
+                </a:solidFill>
+                <a:latin typeface="Calibri"/>
+              </a:defRPr>
+            </a:pPr>
+            <a:r>
+              <a:t>Use two-sensor line following from Lesson 6</a:t>
+            </a:r>
+          </a:p>
+          <a:p>
+            <a:pPr lvl="1">
+              <a:spcAft>
+                <a:spcPts val="600"/>
+              </a:spcAft>
+              <a:defRPr sz="1700" b="0">
+                <a:solidFill>
+                  <a:srgbClr val="333333"/>
+                </a:solidFill>
+                <a:latin typeface="Calibri"/>
+              </a:defRPr>
+            </a:pPr>
+            <a:r>
+              <a:t>Add cross detection with and</a:t>
+            </a:r>
+          </a:p>
+          <a:p>
+            <a:pPr lvl="1">
+              <a:spcAft>
+                <a:spcPts val="600"/>
+              </a:spcAft>
+              <a:defRPr sz="1700" b="0">
+                <a:solidFill>
+                  <a:srgbClr val="333333"/>
+                </a:solidFill>
+                <a:latin typeface="Calibri"/>
+              </a:defRPr>
+            </a:pPr>
+            <a:r>
+              <a:t>Turn 180° when cross is detected</a:t>
+            </a:r>
+          </a:p>
+          <a:p>
+            <a:pPr>
+              <a:spcAft>
+                <a:spcPts val="600"/>
+              </a:spcAft>
               <a:defRPr sz="1800" b="0">
                 <a:solidFill>
-                  <a:srgbClr val="333333"/>
-                </a:solidFill>
-                <a:latin typeface="Calibri"/>
-              </a:defRPr>
-            </a:pPr>
-            <a:r>
-              <a:t>Proportional control, differential steering</a:t>
-            </a:r>
+                  <a:srgbClr val="000000"/>
+                </a:solidFill>
+                <a:latin typeface="Calibri"/>
+              </a:defRPr>
+            </a:pPr>
           </a:p>
           <a:p>
             <a:pPr>
               <a:spcAft>
                 <a:spcPts val="600"/>
               </a:spcAft>
+              <a:defRPr sz="2200" b="1">
+                <a:solidFill>
+                  <a:srgbClr val="1B3A5C"/>
+                </a:solidFill>
+                <a:latin typeface="Calibri"/>
+              </a:defRPr>
+            </a:pPr>
+            <a:r>
+              <a:t>Exercise 2 (Challenge):</a:t>
+            </a:r>
+          </a:p>
+          <a:p>
+            <a:pPr>
+              <a:spcAft>
+                <a:spcPts val="600"/>
+              </a:spcAft>
               <a:defRPr sz="1800" b="0">
                 <a:solidFill>
                   <a:srgbClr val="333333"/>
@@ -6246,97 +6914,63 @@
               </a:defRPr>
             </a:pPr>
             <a:r>
-              <a:t>All mixed together in one big program</a:t>
-            </a:r>
-          </a:p>
+              <a:t>Count crossings and stop after 4</a:t>
+            </a:r>
+          </a:p>
+        </p:txBody>
+      </p:sp>
+      <p:sp>
+        <p:nvSpPr>
+          <p:cNvPr id="5" name="TextBox 4"/>
+          <p:cNvSpPr txBox="1"/>
+          <p:nvPr/>
+        </p:nvSpPr>
+        <p:spPr>
+          <a:xfrm>
+            <a:off x="6858000" y="1371600"/>
+            <a:ext cx="4572000" cy="2743200"/>
+          </a:xfrm>
+          <a:prstGeom prst="rect">
+            <a:avLst/>
+          </a:prstGeom>
+          <a:noFill/>
+        </p:spPr>
+        <p:txBody>
+          <a:bodyPr wrap="square">
+            <a:spAutoFit/>
+          </a:bodyPr>
+          <a:lstStyle/>
+          <a:p/>
           <a:p>
             <a:pPr>
               <a:spcAft>
                 <a:spcPts val="600"/>
               </a:spcAft>
+              <a:defRPr sz="2200" b="1">
+                <a:solidFill>
+                  <a:srgbClr val="2E75B6"/>
+                </a:solidFill>
+                <a:latin typeface="Calibri"/>
+              </a:defRPr>
+            </a:pPr>
+            <a:r>
+              <a:t>Test:</a:t>
+            </a:r>
+          </a:p>
+          <a:p>
+            <a:pPr>
+              <a:spcAft>
+                <a:spcPts val="600"/>
+              </a:spcAft>
               <a:defRPr sz="1800" b="0">
                 <a:solidFill>
-                  <a:srgbClr val="000000"/>
-                </a:solidFill>
-                <a:latin typeface="Calibri"/>
-              </a:defRPr>
-            </a:pPr>
-          </a:p>
-          <a:p>
-            <a:pPr>
-              <a:spcAft>
-                <a:spcPts val="600"/>
-              </a:spcAft>
-              <a:defRPr sz="2200" b="1">
-                <a:solidFill>
-                  <a:srgbClr val="1B3A5C"/>
-                </a:solidFill>
-                <a:latin typeface="Calibri"/>
-              </a:defRPr>
-            </a:pPr>
-            <a:r>
-              <a:t>Next (Lesson 8): Package sensor logic into a LineSensor class</a:t>
-            </a:r>
-          </a:p>
-          <a:p>
-            <a:pPr>
-              <a:spcAft>
-                <a:spcPts val="600"/>
-              </a:spcAft>
-              <a:defRPr sz="1800" b="0">
-                <a:solidFill>
-                  <a:srgbClr val="333333"/>
-                </a:solidFill>
-                <a:latin typeface="Calibri"/>
-              </a:defRPr>
-            </a:pPr>
-            <a:r>
-              <a:t>get_error(),  is_at_cross(),  is_off_line()</a:t>
-            </a:r>
-          </a:p>
-          <a:p>
-            <a:pPr>
-              <a:spcAft>
-                <a:spcPts val="600"/>
-              </a:spcAft>
-              <a:defRPr sz="1800" b="0">
-                <a:solidFill>
-                  <a:srgbClr val="333333"/>
-                </a:solidFill>
-                <a:latin typeface="Calibri"/>
-              </a:defRPr>
-            </a:pPr>
-            <a:r>
-              <a:t>First time writing a Python class!</a:t>
-            </a:r>
-          </a:p>
-          <a:p>
-            <a:pPr>
-              <a:spcAft>
-                <a:spcPts val="600"/>
-              </a:spcAft>
-              <a:defRPr sz="1800" b="0">
-                <a:solidFill>
-                  <a:srgbClr val="000000"/>
-                </a:solidFill>
-                <a:latin typeface="Calibri"/>
-              </a:defRPr>
-            </a:pPr>
-          </a:p>
-          <a:p>
-            <a:pPr>
-              <a:spcAft>
-                <a:spcPts val="600"/>
-              </a:spcAft>
-              <a:defRPr sz="2000" b="1">
-                <a:solidFill>
-                  <a:srgbClr val="2E75B6"/>
-                </a:solidFill>
-                <a:latin typeface="Calibri"/>
-              </a:defRPr>
-            </a:pPr>
-            <a:r>
-              <a:t>Why? Organized code is easier to understand, test, and reuse.</a:t>
+                  <a:srgbClr val="333333"/>
+                </a:solidFill>
+                <a:latin typeface="Calibri"/>
+              </a:defRPr>
+            </a:pPr>
+            <a:r>
+              <a:t>Does the robot reliably detect the cross?</a:t>
             </a:r>
           </a:p>
         </p:txBody>

</xml_diff>